<commit_message>
Dark theme + toggle, citation persistence, retrieval tuning, doc upload, cost figures
- Frontend: dark theme by default + header light/dark toggle (persisted); CSP-safe theme init in bundle
- Persist per-message citations so past/restored answers keep clickable sources
- Fix SSE framing so multi-paragraph answers retain citations
- Retrieval: drop title-only chunks; allow top-ranked doc up to 3 chunks (fixes restricted-data/attendance recall)
- Admin document upload endpoint; two-tier employee/admin API-key auth; conversation history sidebar
- Design doc + deck: real measured cost figures (per-1K, pilot, production); architecture diagram (draw.io/PNG/SVG)
- Dockerfile $PORT bind + healthcheck; .dockerignore excludes deliverable docs

Co-Authored-By: Claude Opus 4.8 <noreply@anthropic.com>
</commit_message>
<xml_diff>
--- a/Meridian_Week1_Presentation.pptx
+++ b/Meridian_Week1_Presentation.pptx
@@ -5239,12 +5239,43 @@
             <a:r>
               <a:rPr sz="1250" b="1" i="0">
                 <a:solidFill>
-                  <a:srgbClr val="E3434A"/>
-                </a:solidFill>
-                <a:latin typeface="Inter"/>
-                <a:cs typeface="Inter"/>
-              </a:rPr>
-              <a:t>[VERIFY] — compare_models.py output not captured</a:t>
+                  <a:srgbClr val="182127"/>
+                </a:solidFill>
+                <a:latin typeface="Inter"/>
+                <a:cs typeface="Inter"/>
+              </a:rPr>
+              <a:t>~$33 / mo   ($16.35 / 1K queries)</a:t>
+            </a:r>
+          </a:p>
+          <a:p>
+            <a:pPr algn="l">
+              <a:spcBef>
+                <a:spcPts val="0"/>
+              </a:spcBef>
+              <a:spcAft>
+                <a:spcPts val="900"/>
+              </a:spcAft>
+              <a:buNone/>
+            </a:pPr>
+            <a:r>
+              <a:rPr sz="1250" b="0" i="0">
+                <a:solidFill>
+                  <a:srgbClr val="5B666E"/>
+                </a:solidFill>
+                <a:latin typeface="Inter"/>
+                <a:cs typeface="Inter"/>
+              </a:rPr>
+              <a:t>All-in   </a:t>
+            </a:r>
+            <a:r>
+              <a:rPr sz="1250" b="1" i="0">
+                <a:solidFill>
+                  <a:srgbClr val="FC7900"/>
+                </a:solidFill>
+                <a:latin typeface="Inter"/>
+                <a:cs typeface="Inter"/>
+              </a:rPr>
+              <a:t>~$121 / mo   (~$1.21 / user)</a:t>
             </a:r>
           </a:p>
         </p:txBody>
@@ -5439,7 +5470,7 @@
                 <a:latin typeface="Inter"/>
                 <a:cs typeface="Inter"/>
               </a:rPr>
-              <a:t>App Service Standard   </a:t>
+              <a:t>App Service Standard S1   </a:t>
             </a:r>
             <a:r>
               <a:rPr sz="1250" b="1" i="0">
@@ -5449,7 +5480,7 @@
                 <a:latin typeface="Inter"/>
                 <a:cs typeface="Inter"/>
               </a:rPr>
-              <a:t>Always On + autoscale</a:t>
+              <a:t>~$73 / mo</a:t>
             </a:r>
           </a:p>
           <a:p>
@@ -5480,7 +5511,7 @@
                 <a:latin typeface="Inter"/>
                 <a:cs typeface="Inter"/>
               </a:rPr>
-              <a:t>multi-partition / replica</a:t>
+              <a:t>~$245 / mo</a:t>
             </a:r>
           </a:p>
           <a:p>
@@ -5501,17 +5532,48 @@
                 <a:latin typeface="Inter"/>
                 <a:cs typeface="Inter"/>
               </a:rPr>
-              <a:t>Generation   </a:t>
+              <a:t>Generation (GPT-5.5)   </a:t>
             </a:r>
             <a:r>
               <a:rPr sz="1250" b="1" i="0">
                 <a:solidFill>
-                  <a:srgbClr val="E3434A"/>
-                </a:solidFill>
-                <a:latin typeface="Inter"/>
-                <a:cs typeface="Inter"/>
-              </a:rPr>
-              <a:t>[VERIFY] — ~ pilot figure × 50 (illustrative)</a:t>
+                  <a:srgbClr val="182127"/>
+                </a:solidFill>
+                <a:latin typeface="Inter"/>
+                <a:cs typeface="Inter"/>
+              </a:rPr>
+              <a:t>~$1,635 / mo   ($16.35 / 1K)</a:t>
+            </a:r>
+          </a:p>
+          <a:p>
+            <a:pPr algn="l">
+              <a:spcBef>
+                <a:spcPts val="0"/>
+              </a:spcBef>
+              <a:spcAft>
+                <a:spcPts val="900"/>
+              </a:spcAft>
+              <a:buNone/>
+            </a:pPr>
+            <a:r>
+              <a:rPr sz="1250" b="0" i="0">
+                <a:solidFill>
+                  <a:srgbClr val="5B666E"/>
+                </a:solidFill>
+                <a:latin typeface="Inter"/>
+                <a:cs typeface="Inter"/>
+              </a:rPr>
+              <a:t>All-in   </a:t>
+            </a:r>
+            <a:r>
+              <a:rPr sz="1250" b="1" i="0">
+                <a:solidFill>
+                  <a:srgbClr val="FC7900"/>
+                </a:solidFill>
+                <a:latin typeface="Inter"/>
+                <a:cs typeface="Inter"/>
+              </a:rPr>
+              <a:t>~$1,953 / mo   ·   ~$486 w/ DeepSeek</a:t>
             </a:r>
           </a:p>
         </p:txBody>
@@ -5666,7 +5728,7 @@
                 <a:latin typeface="Inter"/>
                 <a:cs typeface="Inter"/>
               </a:rPr>
-              <a:t>generation cost dominates as volume grows. At production scale a cost-tiered router — DeepSeek default, GPT-5.5 escalation on low-confidence retrieval — is the recommended architecture.</a:t>
+              <a:t>generation cost dominates as volume grows — at 100K queries/mo it is ~$1,635 vs ~$318 infra. A cost-tiered router (DeepSeek default, GPT-5.5 escalation on low-confidence retrieval) cuts the monthly total from ~$1,953 to ~$486.</a:t>
             </a:r>
           </a:p>
         </p:txBody>
@@ -9432,1369 +9494,40 @@
           </a:p>
         </p:txBody>
       </p:sp>
-      <p:sp>
-        <p:nvSpPr>
-          <p:cNvPr id="6" name="Rounded Rectangle 5"/>
-          <p:cNvSpPr/>
-          <p:nvPr/>
-        </p:nvSpPr>
-        <p:spPr>
-          <a:xfrm>
-            <a:off x="640080" y="2286000"/>
-            <a:ext cx="2121408" cy="1371600"/>
-          </a:xfrm>
-          <a:prstGeom prst="roundRect">
-            <a:avLst>
-              <a:gd name="adj" fmla="val 9000"/>
-            </a:avLst>
-          </a:prstGeom>
-          <a:solidFill>
-            <a:srgbClr val="F7F8F9"/>
-          </a:solidFill>
-          <a:ln w="12700">
-            <a:solidFill>
-              <a:srgbClr val="E2E5E8"/>
-            </a:solidFill>
-          </a:ln>
-          <a:effectLst>
-            <a:outerShdw blurRad="90000" dist="38000" dir="5400000" rotWithShape="0">
-              <a:srgbClr val="182127">
-                <a:alpha val="16000"/>
-              </a:srgbClr>
-            </a:outerShdw>
-          </a:effectLst>
-        </p:spPr>
-        <p:style>
-          <a:lnRef idx="1">
-            <a:schemeClr val="accent1"/>
-          </a:lnRef>
-          <a:fillRef idx="3">
-            <a:schemeClr val="accent1"/>
-          </a:fillRef>
-          <a:effectRef idx="2">
-            <a:schemeClr val="accent1"/>
-          </a:effectRef>
-          <a:fontRef idx="minor">
-            <a:schemeClr val="lt1"/>
-          </a:fontRef>
-        </p:style>
-        <p:txBody>
-          <a:bodyPr rtlCol="0" anchor="ctr"/>
-          <a:lstStyle/>
-          <a:p>
-            <a:pPr algn="ctr"/>
-          </a:p>
-        </p:txBody>
-      </p:sp>
-      <p:sp>
-        <p:nvSpPr>
-          <p:cNvPr id="7" name="Rectangle 6"/>
-          <p:cNvSpPr/>
-          <p:nvPr/>
-        </p:nvSpPr>
-        <p:spPr>
-          <a:xfrm>
-            <a:off x="640080" y="2286000"/>
-            <a:ext cx="2121408" cy="109728"/>
-          </a:xfrm>
-          <a:prstGeom prst="rect">
-            <a:avLst/>
-          </a:prstGeom>
-          <a:gradFill>
-            <a:gsLst>
-              <a:gs pos="0">
-                <a:srgbClr val="F4AD0B"/>
-              </a:gs>
-              <a:gs pos="50000">
-                <a:srgbClr val="FC7900"/>
-              </a:gs>
-              <a:gs pos="100000">
-                <a:srgbClr val="E3434A"/>
-              </a:gs>
-            </a:gsLst>
-            <a:lin ang="0" scaled="1"/>
-          </a:gradFill>
-          <a:ln>
-            <a:noFill/>
-          </a:ln>
-          <a:effectLst/>
-        </p:spPr>
-        <p:style>
-          <a:lnRef idx="1">
-            <a:schemeClr val="accent1"/>
-          </a:lnRef>
-          <a:fillRef idx="3">
-            <a:schemeClr val="accent1"/>
-          </a:fillRef>
-          <a:effectRef idx="2">
-            <a:schemeClr val="accent1"/>
-          </a:effectRef>
-          <a:fontRef idx="minor">
-            <a:schemeClr val="lt1"/>
-          </a:fontRef>
-        </p:style>
-        <p:txBody>
-          <a:bodyPr rtlCol="0" anchor="ctr"/>
-          <a:lstStyle/>
-          <a:p>
-            <a:pPr algn="ctr"/>
-          </a:p>
-        </p:txBody>
-      </p:sp>
-      <p:sp>
-        <p:nvSpPr>
-          <p:cNvPr id="8" name="TextBox 7"/>
+      <p:pic>
+        <p:nvPicPr>
+          <p:cNvPr id="6" name="Picture 5" descr="Meridian_Architecture.png"/>
+          <p:cNvPicPr>
+            <a:picLocks noChangeAspect="1"/>
+          </p:cNvPicPr>
+          <p:nvPr/>
+        </p:nvPicPr>
+        <p:blipFill>
+          <a:blip r:embed="rId2"/>
+          <a:stretch>
+            <a:fillRect/>
+          </a:stretch>
+        </p:blipFill>
+        <p:spPr>
+          <a:xfrm>
+            <a:off x="2767431" y="1847088"/>
+            <a:ext cx="6656832" cy="4160520"/>
+          </a:xfrm>
+          <a:prstGeom prst="rect">
+            <a:avLst/>
+          </a:prstGeom>
+        </p:spPr>
+      </p:pic>
+      <p:sp>
+        <p:nvSpPr>
+          <p:cNvPr id="7" name="TextBox 6"/>
           <p:cNvSpPr txBox="1"/>
           <p:nvPr/>
         </p:nvSpPr>
         <p:spPr>
           <a:xfrm>
-            <a:off x="786384" y="2542032"/>
-            <a:ext cx="1828800" cy="1005840"/>
-          </a:xfrm>
-          <a:prstGeom prst="rect">
-            <a:avLst/>
-          </a:prstGeom>
-          <a:noFill/>
-        </p:spPr>
-        <p:txBody>
-          <a:bodyPr wrap="square" anchor="ctr" lIns="0" rIns="0" tIns="0" bIns="0">
-            <a:spAutoFit/>
-          </a:bodyPr>
-          <a:lstStyle/>
-          <a:p>
-            <a:pPr algn="ctr">
-              <a:spcBef>
-                <a:spcPts val="0"/>
-              </a:spcBef>
-              <a:spcAft>
-                <a:spcPts val="400"/>
-              </a:spcAft>
-              <a:buNone/>
-            </a:pPr>
-            <a:r>
-              <a:rPr sz="1400" b="1" i="0">
-                <a:solidFill>
-                  <a:srgbClr val="182127"/>
-                </a:solidFill>
-                <a:latin typeface="Inter"/>
-                <a:cs typeface="Inter"/>
-              </a:rPr>
-              <a:t>React SPA</a:t>
-            </a:r>
-          </a:p>
-          <a:p>
-            <a:pPr algn="ctr">
-              <a:spcBef>
-                <a:spcPts val="0"/>
-              </a:spcBef>
-              <a:spcAft>
-                <a:spcPts val="600"/>
-              </a:spcAft>
-              <a:buNone/>
-            </a:pPr>
-            <a:r>
-              <a:rPr sz="1000" b="0" i="0">
-                <a:solidFill>
-                  <a:srgbClr val="5B666E"/>
-                </a:solidFill>
-                <a:latin typeface="Inter"/>
-                <a:cs typeface="Inter"/>
-              </a:rPr>
-              <a:t>Chat · history · citations</a:t>
-            </a:r>
-          </a:p>
-        </p:txBody>
-      </p:sp>
-      <p:sp>
-        <p:nvSpPr>
-          <p:cNvPr id="9" name="Right Arrow 8"/>
-          <p:cNvSpPr/>
-          <p:nvPr/>
-        </p:nvSpPr>
-        <p:spPr>
-          <a:xfrm>
-            <a:off x="2766060" y="2889504"/>
-            <a:ext cx="155448" cy="164592"/>
-          </a:xfrm>
-          <a:prstGeom prst="rightArrow">
-            <a:avLst>
-              <a:gd name="adj1" fmla="val 50000"/>
-              <a:gd name="adj2" fmla="val 55000"/>
-            </a:avLst>
-          </a:prstGeom>
-          <a:solidFill>
-            <a:srgbClr val="FC7900"/>
-          </a:solidFill>
-          <a:ln>
-            <a:noFill/>
-          </a:ln>
-          <a:effectLst/>
-        </p:spPr>
-        <p:style>
-          <a:lnRef idx="1">
-            <a:schemeClr val="accent1"/>
-          </a:lnRef>
-          <a:fillRef idx="3">
-            <a:schemeClr val="accent1"/>
-          </a:fillRef>
-          <a:effectRef idx="2">
-            <a:schemeClr val="accent1"/>
-          </a:effectRef>
-          <a:fontRef idx="minor">
-            <a:schemeClr val="lt1"/>
-          </a:fontRef>
-        </p:style>
-        <p:txBody>
-          <a:bodyPr rtlCol="0" anchor="ctr"/>
-          <a:lstStyle/>
-          <a:p>
-            <a:pPr algn="ctr"/>
-          </a:p>
-        </p:txBody>
-      </p:sp>
-      <p:sp>
-        <p:nvSpPr>
-          <p:cNvPr id="10" name="Rounded Rectangle 9"/>
-          <p:cNvSpPr/>
-          <p:nvPr/>
-        </p:nvSpPr>
-        <p:spPr>
-          <a:xfrm>
-            <a:off x="2926080" y="2286000"/>
-            <a:ext cx="2121408" cy="1371600"/>
-          </a:xfrm>
-          <a:prstGeom prst="roundRect">
-            <a:avLst>
-              <a:gd name="adj" fmla="val 9000"/>
-            </a:avLst>
-          </a:prstGeom>
-          <a:solidFill>
-            <a:srgbClr val="F7F8F9"/>
-          </a:solidFill>
-          <a:ln w="12700">
-            <a:solidFill>
-              <a:srgbClr val="E2E5E8"/>
-            </a:solidFill>
-          </a:ln>
-          <a:effectLst>
-            <a:outerShdw blurRad="90000" dist="38000" dir="5400000" rotWithShape="0">
-              <a:srgbClr val="182127">
-                <a:alpha val="16000"/>
-              </a:srgbClr>
-            </a:outerShdw>
-          </a:effectLst>
-        </p:spPr>
-        <p:style>
-          <a:lnRef idx="1">
-            <a:schemeClr val="accent1"/>
-          </a:lnRef>
-          <a:fillRef idx="3">
-            <a:schemeClr val="accent1"/>
-          </a:fillRef>
-          <a:effectRef idx="2">
-            <a:schemeClr val="accent1"/>
-          </a:effectRef>
-          <a:fontRef idx="minor">
-            <a:schemeClr val="lt1"/>
-          </a:fontRef>
-        </p:style>
-        <p:txBody>
-          <a:bodyPr rtlCol="0" anchor="ctr"/>
-          <a:lstStyle/>
-          <a:p>
-            <a:pPr algn="ctr"/>
-          </a:p>
-        </p:txBody>
-      </p:sp>
-      <p:sp>
-        <p:nvSpPr>
-          <p:cNvPr id="11" name="Rectangle 10"/>
-          <p:cNvSpPr/>
-          <p:nvPr/>
-        </p:nvSpPr>
-        <p:spPr>
-          <a:xfrm>
-            <a:off x="2926080" y="2286000"/>
-            <a:ext cx="2121408" cy="109728"/>
-          </a:xfrm>
-          <a:prstGeom prst="rect">
-            <a:avLst/>
-          </a:prstGeom>
-          <a:gradFill>
-            <a:gsLst>
-              <a:gs pos="0">
-                <a:srgbClr val="F4AD0B"/>
-              </a:gs>
-              <a:gs pos="50000">
-                <a:srgbClr val="FC7900"/>
-              </a:gs>
-              <a:gs pos="100000">
-                <a:srgbClr val="E3434A"/>
-              </a:gs>
-            </a:gsLst>
-            <a:lin ang="0" scaled="1"/>
-          </a:gradFill>
-          <a:ln>
-            <a:noFill/>
-          </a:ln>
-          <a:effectLst/>
-        </p:spPr>
-        <p:style>
-          <a:lnRef idx="1">
-            <a:schemeClr val="accent1"/>
-          </a:lnRef>
-          <a:fillRef idx="3">
-            <a:schemeClr val="accent1"/>
-          </a:fillRef>
-          <a:effectRef idx="2">
-            <a:schemeClr val="accent1"/>
-          </a:effectRef>
-          <a:fontRef idx="minor">
-            <a:schemeClr val="lt1"/>
-          </a:fontRef>
-        </p:style>
-        <p:txBody>
-          <a:bodyPr rtlCol="0" anchor="ctr"/>
-          <a:lstStyle/>
-          <a:p>
-            <a:pPr algn="ctr"/>
-          </a:p>
-        </p:txBody>
-      </p:sp>
-      <p:sp>
-        <p:nvSpPr>
-          <p:cNvPr id="12" name="TextBox 11"/>
-          <p:cNvSpPr txBox="1"/>
-          <p:nvPr/>
-        </p:nvSpPr>
-        <p:spPr>
-          <a:xfrm>
-            <a:off x="3072384" y="2542032"/>
-            <a:ext cx="1828800" cy="1005840"/>
-          </a:xfrm>
-          <a:prstGeom prst="rect">
-            <a:avLst/>
-          </a:prstGeom>
-          <a:noFill/>
-        </p:spPr>
-        <p:txBody>
-          <a:bodyPr wrap="square" anchor="ctr" lIns="0" rIns="0" tIns="0" bIns="0">
-            <a:spAutoFit/>
-          </a:bodyPr>
-          <a:lstStyle/>
-          <a:p>
-            <a:pPr algn="ctr">
-              <a:spcBef>
-                <a:spcPts val="0"/>
-              </a:spcBef>
-              <a:spcAft>
-                <a:spcPts val="400"/>
-              </a:spcAft>
-              <a:buNone/>
-            </a:pPr>
-            <a:r>
-              <a:rPr sz="1400" b="1" i="0">
-                <a:solidFill>
-                  <a:srgbClr val="182127"/>
-                </a:solidFill>
-                <a:latin typeface="Inter"/>
-                <a:cs typeface="Inter"/>
-              </a:rPr>
-              <a:t>FastAPI</a:t>
-            </a:r>
-          </a:p>
-          <a:p>
-            <a:pPr algn="ctr">
-              <a:spcBef>
-                <a:spcPts val="0"/>
-              </a:spcBef>
-              <a:spcAft>
-                <a:spcPts val="600"/>
-              </a:spcAft>
-              <a:buNone/>
-            </a:pPr>
-            <a:r>
-              <a:rPr sz="1000" b="0" i="0">
-                <a:solidFill>
-                  <a:srgbClr val="5B666E"/>
-                </a:solidFill>
-                <a:latin typeface="Inter"/>
-                <a:cs typeface="Inter"/>
-              </a:rPr>
-              <a:t>Single origin · 2-key auth · SSE</a:t>
-            </a:r>
-          </a:p>
-        </p:txBody>
-      </p:sp>
-      <p:sp>
-        <p:nvSpPr>
-          <p:cNvPr id="13" name="Right Arrow 12"/>
-          <p:cNvSpPr/>
-          <p:nvPr/>
-        </p:nvSpPr>
-        <p:spPr>
-          <a:xfrm>
-            <a:off x="5052060" y="2889504"/>
-            <a:ext cx="155448" cy="164592"/>
-          </a:xfrm>
-          <a:prstGeom prst="rightArrow">
-            <a:avLst>
-              <a:gd name="adj1" fmla="val 50000"/>
-              <a:gd name="adj2" fmla="val 55000"/>
-            </a:avLst>
-          </a:prstGeom>
-          <a:solidFill>
-            <a:srgbClr val="FC7900"/>
-          </a:solidFill>
-          <a:ln>
-            <a:noFill/>
-          </a:ln>
-          <a:effectLst/>
-        </p:spPr>
-        <p:style>
-          <a:lnRef idx="1">
-            <a:schemeClr val="accent1"/>
-          </a:lnRef>
-          <a:fillRef idx="3">
-            <a:schemeClr val="accent1"/>
-          </a:fillRef>
-          <a:effectRef idx="2">
-            <a:schemeClr val="accent1"/>
-          </a:effectRef>
-          <a:fontRef idx="minor">
-            <a:schemeClr val="lt1"/>
-          </a:fontRef>
-        </p:style>
-        <p:txBody>
-          <a:bodyPr rtlCol="0" anchor="ctr"/>
-          <a:lstStyle/>
-          <a:p>
-            <a:pPr algn="ctr"/>
-          </a:p>
-        </p:txBody>
-      </p:sp>
-      <p:sp>
-        <p:nvSpPr>
-          <p:cNvPr id="14" name="Rounded Rectangle 13"/>
-          <p:cNvSpPr/>
-          <p:nvPr/>
-        </p:nvSpPr>
-        <p:spPr>
-          <a:xfrm>
-            <a:off x="5212080" y="2286000"/>
-            <a:ext cx="2121408" cy="1371600"/>
-          </a:xfrm>
-          <a:prstGeom prst="roundRect">
-            <a:avLst>
-              <a:gd name="adj" fmla="val 9000"/>
-            </a:avLst>
-          </a:prstGeom>
-          <a:solidFill>
-            <a:srgbClr val="F7F8F9"/>
-          </a:solidFill>
-          <a:ln w="12700">
-            <a:solidFill>
-              <a:srgbClr val="E2E5E8"/>
-            </a:solidFill>
-          </a:ln>
-          <a:effectLst>
-            <a:outerShdw blurRad="90000" dist="38000" dir="5400000" rotWithShape="0">
-              <a:srgbClr val="182127">
-                <a:alpha val="16000"/>
-              </a:srgbClr>
-            </a:outerShdw>
-          </a:effectLst>
-        </p:spPr>
-        <p:style>
-          <a:lnRef idx="1">
-            <a:schemeClr val="accent1"/>
-          </a:lnRef>
-          <a:fillRef idx="3">
-            <a:schemeClr val="accent1"/>
-          </a:fillRef>
-          <a:effectRef idx="2">
-            <a:schemeClr val="accent1"/>
-          </a:effectRef>
-          <a:fontRef idx="minor">
-            <a:schemeClr val="lt1"/>
-          </a:fontRef>
-        </p:style>
-        <p:txBody>
-          <a:bodyPr rtlCol="0" anchor="ctr"/>
-          <a:lstStyle/>
-          <a:p>
-            <a:pPr algn="ctr"/>
-          </a:p>
-        </p:txBody>
-      </p:sp>
-      <p:sp>
-        <p:nvSpPr>
-          <p:cNvPr id="15" name="Rectangle 14"/>
-          <p:cNvSpPr/>
-          <p:nvPr/>
-        </p:nvSpPr>
-        <p:spPr>
-          <a:xfrm>
-            <a:off x="5212080" y="2286000"/>
-            <a:ext cx="2121408" cy="109728"/>
-          </a:xfrm>
-          <a:prstGeom prst="rect">
-            <a:avLst/>
-          </a:prstGeom>
-          <a:gradFill>
-            <a:gsLst>
-              <a:gs pos="0">
-                <a:srgbClr val="F4AD0B"/>
-              </a:gs>
-              <a:gs pos="50000">
-                <a:srgbClr val="FC7900"/>
-              </a:gs>
-              <a:gs pos="100000">
-                <a:srgbClr val="E3434A"/>
-              </a:gs>
-            </a:gsLst>
-            <a:lin ang="0" scaled="1"/>
-          </a:gradFill>
-          <a:ln>
-            <a:noFill/>
-          </a:ln>
-          <a:effectLst/>
-        </p:spPr>
-        <p:style>
-          <a:lnRef idx="1">
-            <a:schemeClr val="accent1"/>
-          </a:lnRef>
-          <a:fillRef idx="3">
-            <a:schemeClr val="accent1"/>
-          </a:fillRef>
-          <a:effectRef idx="2">
-            <a:schemeClr val="accent1"/>
-          </a:effectRef>
-          <a:fontRef idx="minor">
-            <a:schemeClr val="lt1"/>
-          </a:fontRef>
-        </p:style>
-        <p:txBody>
-          <a:bodyPr rtlCol="0" anchor="ctr"/>
-          <a:lstStyle/>
-          <a:p>
-            <a:pPr algn="ctr"/>
-          </a:p>
-        </p:txBody>
-      </p:sp>
-      <p:sp>
-        <p:nvSpPr>
-          <p:cNvPr id="16" name="TextBox 15"/>
-          <p:cNvSpPr txBox="1"/>
-          <p:nvPr/>
-        </p:nvSpPr>
-        <p:spPr>
-          <a:xfrm>
-            <a:off x="5358384" y="2542032"/>
-            <a:ext cx="1828800" cy="1005840"/>
-          </a:xfrm>
-          <a:prstGeom prst="rect">
-            <a:avLst/>
-          </a:prstGeom>
-          <a:noFill/>
-        </p:spPr>
-        <p:txBody>
-          <a:bodyPr wrap="square" anchor="ctr" lIns="0" rIns="0" tIns="0" bIns="0">
-            <a:spAutoFit/>
-          </a:bodyPr>
-          <a:lstStyle/>
-          <a:p>
-            <a:pPr algn="ctr">
-              <a:spcBef>
-                <a:spcPts val="0"/>
-              </a:spcBef>
-              <a:spcAft>
-                <a:spcPts val="400"/>
-              </a:spcAft>
-              <a:buNone/>
-            </a:pPr>
-            <a:r>
-              <a:rPr sz="1400" b="1" i="0">
-                <a:solidFill>
-                  <a:srgbClr val="182127"/>
-                </a:solidFill>
-                <a:latin typeface="Inter"/>
-                <a:cs typeface="Inter"/>
-              </a:rPr>
-              <a:t>Relevance gate</a:t>
-            </a:r>
-          </a:p>
-          <a:p>
-            <a:pPr algn="ctr">
-              <a:spcBef>
-                <a:spcPts val="0"/>
-              </a:spcBef>
-              <a:spcAft>
-                <a:spcPts val="600"/>
-              </a:spcAft>
-              <a:buNone/>
-            </a:pPr>
-            <a:r>
-              <a:rPr sz="1000" b="0" i="0">
-                <a:solidFill>
-                  <a:srgbClr val="5B666E"/>
-                </a:solidFill>
-                <a:latin typeface="Inter"/>
-                <a:cs typeface="Inter"/>
-              </a:rPr>
-              <a:t>Two-signal · refuse pre-LLM</a:t>
-            </a:r>
-          </a:p>
-        </p:txBody>
-      </p:sp>
-      <p:sp>
-        <p:nvSpPr>
-          <p:cNvPr id="17" name="Right Arrow 16"/>
-          <p:cNvSpPr/>
-          <p:nvPr/>
-        </p:nvSpPr>
-        <p:spPr>
-          <a:xfrm>
-            <a:off x="7338060" y="2889504"/>
-            <a:ext cx="155448" cy="164592"/>
-          </a:xfrm>
-          <a:prstGeom prst="rightArrow">
-            <a:avLst>
-              <a:gd name="adj1" fmla="val 50000"/>
-              <a:gd name="adj2" fmla="val 55000"/>
-            </a:avLst>
-          </a:prstGeom>
-          <a:solidFill>
-            <a:srgbClr val="FC7900"/>
-          </a:solidFill>
-          <a:ln>
-            <a:noFill/>
-          </a:ln>
-          <a:effectLst/>
-        </p:spPr>
-        <p:style>
-          <a:lnRef idx="1">
-            <a:schemeClr val="accent1"/>
-          </a:lnRef>
-          <a:fillRef idx="3">
-            <a:schemeClr val="accent1"/>
-          </a:fillRef>
-          <a:effectRef idx="2">
-            <a:schemeClr val="accent1"/>
-          </a:effectRef>
-          <a:fontRef idx="minor">
-            <a:schemeClr val="lt1"/>
-          </a:fontRef>
-        </p:style>
-        <p:txBody>
-          <a:bodyPr rtlCol="0" anchor="ctr"/>
-          <a:lstStyle/>
-          <a:p>
-            <a:pPr algn="ctr"/>
-          </a:p>
-        </p:txBody>
-      </p:sp>
-      <p:sp>
-        <p:nvSpPr>
-          <p:cNvPr id="18" name="Rounded Rectangle 17"/>
-          <p:cNvSpPr/>
-          <p:nvPr/>
-        </p:nvSpPr>
-        <p:spPr>
-          <a:xfrm>
-            <a:off x="7498080" y="2286000"/>
-            <a:ext cx="2121408" cy="1371600"/>
-          </a:xfrm>
-          <a:prstGeom prst="roundRect">
-            <a:avLst>
-              <a:gd name="adj" fmla="val 9000"/>
-            </a:avLst>
-          </a:prstGeom>
-          <a:solidFill>
-            <a:srgbClr val="F7F8F9"/>
-          </a:solidFill>
-          <a:ln w="12700">
-            <a:solidFill>
-              <a:srgbClr val="E2E5E8"/>
-            </a:solidFill>
-          </a:ln>
-          <a:effectLst>
-            <a:outerShdw blurRad="90000" dist="38000" dir="5400000" rotWithShape="0">
-              <a:srgbClr val="182127">
-                <a:alpha val="16000"/>
-              </a:srgbClr>
-            </a:outerShdw>
-          </a:effectLst>
-        </p:spPr>
-        <p:style>
-          <a:lnRef idx="1">
-            <a:schemeClr val="accent1"/>
-          </a:lnRef>
-          <a:fillRef idx="3">
-            <a:schemeClr val="accent1"/>
-          </a:fillRef>
-          <a:effectRef idx="2">
-            <a:schemeClr val="accent1"/>
-          </a:effectRef>
-          <a:fontRef idx="minor">
-            <a:schemeClr val="lt1"/>
-          </a:fontRef>
-        </p:style>
-        <p:txBody>
-          <a:bodyPr rtlCol="0" anchor="ctr"/>
-          <a:lstStyle/>
-          <a:p>
-            <a:pPr algn="ctr"/>
-          </a:p>
-        </p:txBody>
-      </p:sp>
-      <p:sp>
-        <p:nvSpPr>
-          <p:cNvPr id="19" name="Rounded Rectangle 18"/>
-          <p:cNvSpPr/>
-          <p:nvPr/>
-        </p:nvSpPr>
-        <p:spPr>
-          <a:xfrm>
-            <a:off x="7498080" y="2286000"/>
-            <a:ext cx="2121408" cy="109728"/>
-          </a:xfrm>
-          <a:prstGeom prst="roundRect">
-            <a:avLst>
-              <a:gd name="adj" fmla="val 2000"/>
-            </a:avLst>
-          </a:prstGeom>
-          <a:solidFill>
-            <a:srgbClr val="2A363E"/>
-          </a:solidFill>
-          <a:ln>
-            <a:noFill/>
-          </a:ln>
-          <a:effectLst/>
-        </p:spPr>
-        <p:style>
-          <a:lnRef idx="1">
-            <a:schemeClr val="accent1"/>
-          </a:lnRef>
-          <a:fillRef idx="3">
-            <a:schemeClr val="accent1"/>
-          </a:fillRef>
-          <a:effectRef idx="2">
-            <a:schemeClr val="accent1"/>
-          </a:effectRef>
-          <a:fontRef idx="minor">
-            <a:schemeClr val="lt1"/>
-          </a:fontRef>
-        </p:style>
-        <p:txBody>
-          <a:bodyPr rtlCol="0" anchor="ctr"/>
-          <a:lstStyle/>
-          <a:p>
-            <a:pPr algn="ctr"/>
-          </a:p>
-        </p:txBody>
-      </p:sp>
-      <p:sp>
-        <p:nvSpPr>
-          <p:cNvPr id="20" name="TextBox 19"/>
-          <p:cNvSpPr txBox="1"/>
-          <p:nvPr/>
-        </p:nvSpPr>
-        <p:spPr>
-          <a:xfrm>
-            <a:off x="7644384" y="2542032"/>
-            <a:ext cx="1828800" cy="1005840"/>
-          </a:xfrm>
-          <a:prstGeom prst="rect">
-            <a:avLst/>
-          </a:prstGeom>
-          <a:noFill/>
-        </p:spPr>
-        <p:txBody>
-          <a:bodyPr wrap="square" anchor="ctr" lIns="0" rIns="0" tIns="0" bIns="0">
-            <a:spAutoFit/>
-          </a:bodyPr>
-          <a:lstStyle/>
-          <a:p>
-            <a:pPr algn="ctr">
-              <a:spcBef>
-                <a:spcPts val="0"/>
-              </a:spcBef>
-              <a:spcAft>
-                <a:spcPts val="400"/>
-              </a:spcAft>
-              <a:buNone/>
-            </a:pPr>
-            <a:r>
-              <a:rPr sz="1400" b="1" i="0">
-                <a:solidFill>
-                  <a:srgbClr val="182127"/>
-                </a:solidFill>
-                <a:latin typeface="Inter"/>
-                <a:cs typeface="Inter"/>
-              </a:rPr>
-              <a:t>Azure AI Search</a:t>
-            </a:r>
-          </a:p>
-          <a:p>
-            <a:pPr algn="ctr">
-              <a:spcBef>
-                <a:spcPts val="0"/>
-              </a:spcBef>
-              <a:spcAft>
-                <a:spcPts val="600"/>
-              </a:spcAft>
-              <a:buNone/>
-            </a:pPr>
-            <a:r>
-              <a:rPr sz="1000" b="0" i="0">
-                <a:solidFill>
-                  <a:srgbClr val="5B666E"/>
-                </a:solidFill>
-                <a:latin typeface="Inter"/>
-                <a:cs typeface="Inter"/>
-              </a:rPr>
-              <a:t>Hybrid: vector + keyword</a:t>
-            </a:r>
-          </a:p>
-        </p:txBody>
-      </p:sp>
-      <p:sp>
-        <p:nvSpPr>
-          <p:cNvPr id="21" name="Right Arrow 20"/>
-          <p:cNvSpPr/>
-          <p:nvPr/>
-        </p:nvSpPr>
-        <p:spPr>
-          <a:xfrm>
-            <a:off x="9624060" y="2889504"/>
-            <a:ext cx="155448" cy="164592"/>
-          </a:xfrm>
-          <a:prstGeom prst="rightArrow">
-            <a:avLst>
-              <a:gd name="adj1" fmla="val 50000"/>
-              <a:gd name="adj2" fmla="val 55000"/>
-            </a:avLst>
-          </a:prstGeom>
-          <a:solidFill>
-            <a:srgbClr val="FC7900"/>
-          </a:solidFill>
-          <a:ln>
-            <a:noFill/>
-          </a:ln>
-          <a:effectLst/>
-        </p:spPr>
-        <p:style>
-          <a:lnRef idx="1">
-            <a:schemeClr val="accent1"/>
-          </a:lnRef>
-          <a:fillRef idx="3">
-            <a:schemeClr val="accent1"/>
-          </a:fillRef>
-          <a:effectRef idx="2">
-            <a:schemeClr val="accent1"/>
-          </a:effectRef>
-          <a:fontRef idx="minor">
-            <a:schemeClr val="lt1"/>
-          </a:fontRef>
-        </p:style>
-        <p:txBody>
-          <a:bodyPr rtlCol="0" anchor="ctr"/>
-          <a:lstStyle/>
-          <a:p>
-            <a:pPr algn="ctr"/>
-          </a:p>
-        </p:txBody>
-      </p:sp>
-      <p:sp>
-        <p:nvSpPr>
-          <p:cNvPr id="22" name="Rounded Rectangle 21"/>
-          <p:cNvSpPr/>
-          <p:nvPr/>
-        </p:nvSpPr>
-        <p:spPr>
-          <a:xfrm>
-            <a:off x="9784080" y="2286000"/>
-            <a:ext cx="2121408" cy="1371600"/>
-          </a:xfrm>
-          <a:prstGeom prst="roundRect">
-            <a:avLst>
-              <a:gd name="adj" fmla="val 9000"/>
-            </a:avLst>
-          </a:prstGeom>
-          <a:solidFill>
-            <a:srgbClr val="F7F8F9"/>
-          </a:solidFill>
-          <a:ln w="12700">
-            <a:solidFill>
-              <a:srgbClr val="E2E5E8"/>
-            </a:solidFill>
-          </a:ln>
-          <a:effectLst>
-            <a:outerShdw blurRad="90000" dist="38000" dir="5400000" rotWithShape="0">
-              <a:srgbClr val="182127">
-                <a:alpha val="16000"/>
-              </a:srgbClr>
-            </a:outerShdw>
-          </a:effectLst>
-        </p:spPr>
-        <p:style>
-          <a:lnRef idx="1">
-            <a:schemeClr val="accent1"/>
-          </a:lnRef>
-          <a:fillRef idx="3">
-            <a:schemeClr val="accent1"/>
-          </a:fillRef>
-          <a:effectRef idx="2">
-            <a:schemeClr val="accent1"/>
-          </a:effectRef>
-          <a:fontRef idx="minor">
-            <a:schemeClr val="lt1"/>
-          </a:fontRef>
-        </p:style>
-        <p:txBody>
-          <a:bodyPr rtlCol="0" anchor="ctr"/>
-          <a:lstStyle/>
-          <a:p>
-            <a:pPr algn="ctr"/>
-          </a:p>
-        </p:txBody>
-      </p:sp>
-      <p:sp>
-        <p:nvSpPr>
-          <p:cNvPr id="23" name="Rounded Rectangle 22"/>
-          <p:cNvSpPr/>
-          <p:nvPr/>
-        </p:nvSpPr>
-        <p:spPr>
-          <a:xfrm>
-            <a:off x="9784080" y="2286000"/>
-            <a:ext cx="2121408" cy="109728"/>
-          </a:xfrm>
-          <a:prstGeom prst="roundRect">
-            <a:avLst>
-              <a:gd name="adj" fmla="val 2000"/>
-            </a:avLst>
-          </a:prstGeom>
-          <a:solidFill>
-            <a:srgbClr val="2A363E"/>
-          </a:solidFill>
-          <a:ln>
-            <a:noFill/>
-          </a:ln>
-          <a:effectLst/>
-        </p:spPr>
-        <p:style>
-          <a:lnRef idx="1">
-            <a:schemeClr val="accent1"/>
-          </a:lnRef>
-          <a:fillRef idx="3">
-            <a:schemeClr val="accent1"/>
-          </a:fillRef>
-          <a:effectRef idx="2">
-            <a:schemeClr val="accent1"/>
-          </a:effectRef>
-          <a:fontRef idx="minor">
-            <a:schemeClr val="lt1"/>
-          </a:fontRef>
-        </p:style>
-        <p:txBody>
-          <a:bodyPr rtlCol="0" anchor="ctr"/>
-          <a:lstStyle/>
-          <a:p>
-            <a:pPr algn="ctr"/>
-          </a:p>
-        </p:txBody>
-      </p:sp>
-      <p:sp>
-        <p:nvSpPr>
-          <p:cNvPr id="24" name="TextBox 23"/>
-          <p:cNvSpPr txBox="1"/>
-          <p:nvPr/>
-        </p:nvSpPr>
-        <p:spPr>
-          <a:xfrm>
-            <a:off x="9930384" y="2542032"/>
-            <a:ext cx="1828800" cy="1005840"/>
-          </a:xfrm>
-          <a:prstGeom prst="rect">
-            <a:avLst/>
-          </a:prstGeom>
-          <a:noFill/>
-        </p:spPr>
-        <p:txBody>
-          <a:bodyPr wrap="square" anchor="ctr" lIns="0" rIns="0" tIns="0" bIns="0">
-            <a:spAutoFit/>
-          </a:bodyPr>
-          <a:lstStyle/>
-          <a:p>
-            <a:pPr algn="ctr">
-              <a:spcBef>
-                <a:spcPts val="0"/>
-              </a:spcBef>
-              <a:spcAft>
-                <a:spcPts val="400"/>
-              </a:spcAft>
-              <a:buNone/>
-            </a:pPr>
-            <a:r>
-              <a:rPr sz="1400" b="1" i="0">
-                <a:solidFill>
-                  <a:srgbClr val="182127"/>
-                </a:solidFill>
-                <a:latin typeface="Inter"/>
-                <a:cs typeface="Inter"/>
-              </a:rPr>
-              <a:t>Azure OpenAI</a:t>
-            </a:r>
-          </a:p>
-          <a:p>
-            <a:pPr algn="ctr">
-              <a:spcBef>
-                <a:spcPts val="0"/>
-              </a:spcBef>
-              <a:spcAft>
-                <a:spcPts val="600"/>
-              </a:spcAft>
-              <a:buNone/>
-            </a:pPr>
-            <a:r>
-              <a:rPr sz="1000" b="0" i="0">
-                <a:solidFill>
-                  <a:srgbClr val="5B666E"/>
-                </a:solidFill>
-                <a:latin typeface="Inter"/>
-                <a:cs typeface="Inter"/>
-              </a:rPr>
-              <a:t>GPT-5.5 · embeddings</a:t>
-            </a:r>
-          </a:p>
-        </p:txBody>
-      </p:sp>
-      <p:sp>
-        <p:nvSpPr>
-          <p:cNvPr id="25" name="Rounded Rectangle 24"/>
-          <p:cNvSpPr/>
-          <p:nvPr/>
-        </p:nvSpPr>
-        <p:spPr>
-          <a:xfrm>
-            <a:off x="640080" y="4023360"/>
-            <a:ext cx="4937760" cy="914400"/>
-          </a:xfrm>
-          <a:prstGeom prst="roundRect">
-            <a:avLst>
-              <a:gd name="adj" fmla="val 10000"/>
-            </a:avLst>
-          </a:prstGeom>
-          <a:solidFill>
-            <a:srgbClr val="F4F5F6"/>
-          </a:solidFill>
-          <a:ln w="12700">
-            <a:solidFill>
-              <a:srgbClr val="E2E5E8"/>
-            </a:solidFill>
-          </a:ln>
-          <a:effectLst/>
-        </p:spPr>
-        <p:style>
-          <a:lnRef idx="1">
-            <a:schemeClr val="accent1"/>
-          </a:lnRef>
-          <a:fillRef idx="3">
-            <a:schemeClr val="accent1"/>
-          </a:fillRef>
-          <a:effectRef idx="2">
-            <a:schemeClr val="accent1"/>
-          </a:effectRef>
-          <a:fontRef idx="minor">
-            <a:schemeClr val="lt1"/>
-          </a:fontRef>
-        </p:style>
-        <p:txBody>
-          <a:bodyPr rtlCol="0" anchor="ctr"/>
-          <a:lstStyle/>
-          <a:p>
-            <a:pPr algn="ctr"/>
-          </a:p>
-        </p:txBody>
-      </p:sp>
-      <p:sp>
-        <p:nvSpPr>
-          <p:cNvPr id="26" name="TextBox 25"/>
-          <p:cNvSpPr txBox="1"/>
-          <p:nvPr/>
-        </p:nvSpPr>
-        <p:spPr>
-          <a:xfrm>
-            <a:off x="868680" y="4133087"/>
-            <a:ext cx="4480560" cy="713232"/>
-          </a:xfrm>
-          <a:prstGeom prst="rect">
-            <a:avLst/>
-          </a:prstGeom>
-          <a:noFill/>
-        </p:spPr>
-        <p:txBody>
-          <a:bodyPr wrap="square" anchor="ctr" lIns="0" rIns="0" tIns="0" bIns="0">
-            <a:spAutoFit/>
-          </a:bodyPr>
-          <a:lstStyle/>
-          <a:p>
-            <a:pPr algn="l">
-              <a:spcBef>
-                <a:spcPts val="0"/>
-              </a:spcBef>
-              <a:spcAft>
-                <a:spcPts val="0"/>
-              </a:spcAft>
-              <a:buNone/>
-            </a:pPr>
-            <a:r>
-              <a:rPr sz="1400" b="1" i="0">
-                <a:solidFill>
-                  <a:srgbClr val="182127"/>
-                </a:solidFill>
-                <a:latin typeface="Inter"/>
-                <a:cs typeface="Inter"/>
-              </a:rPr>
-              <a:t>SQLite  </a:t>
-            </a:r>
-            <a:r>
-              <a:rPr sz="1100" b="0" i="0">
-                <a:solidFill>
-                  <a:srgbClr val="5B666E"/>
-                </a:solidFill>
-                <a:latin typeface="Inter"/>
-                <a:cs typeface="Inter"/>
-              </a:rPr>
-              <a:t>— conversations, messages, chunk metadata, feedback. Vectors live in Azure AI Search, not here.</a:t>
-            </a:r>
-          </a:p>
-        </p:txBody>
-      </p:sp>
-      <p:sp>
-        <p:nvSpPr>
-          <p:cNvPr id="27" name="Rounded Rectangle 26"/>
-          <p:cNvSpPr/>
-          <p:nvPr/>
-        </p:nvSpPr>
-        <p:spPr>
-          <a:xfrm>
-            <a:off x="5760720" y="4023360"/>
-            <a:ext cx="5760720" cy="914400"/>
-          </a:xfrm>
-          <a:prstGeom prst="roundRect">
-            <a:avLst>
-              <a:gd name="adj" fmla="val 10000"/>
-            </a:avLst>
-          </a:prstGeom>
-          <a:solidFill>
-            <a:srgbClr val="F4F5F6"/>
-          </a:solidFill>
-          <a:ln w="12700">
-            <a:solidFill>
-              <a:srgbClr val="E2E5E8"/>
-            </a:solidFill>
-          </a:ln>
-          <a:effectLst/>
-        </p:spPr>
-        <p:style>
-          <a:lnRef idx="1">
-            <a:schemeClr val="accent1"/>
-          </a:lnRef>
-          <a:fillRef idx="3">
-            <a:schemeClr val="accent1"/>
-          </a:fillRef>
-          <a:effectRef idx="2">
-            <a:schemeClr val="accent1"/>
-          </a:effectRef>
-          <a:fontRef idx="minor">
-            <a:schemeClr val="lt1"/>
-          </a:fontRef>
-        </p:style>
-        <p:txBody>
-          <a:bodyPr rtlCol="0" anchor="ctr"/>
-          <a:lstStyle/>
-          <a:p>
-            <a:pPr algn="ctr"/>
-          </a:p>
-        </p:txBody>
-      </p:sp>
-      <p:sp>
-        <p:nvSpPr>
-          <p:cNvPr id="28" name="TextBox 27"/>
-          <p:cNvSpPr txBox="1"/>
-          <p:nvPr/>
-        </p:nvSpPr>
-        <p:spPr>
-          <a:xfrm>
-            <a:off x="5989320" y="4133087"/>
-            <a:ext cx="5303520" cy="713232"/>
-          </a:xfrm>
-          <a:prstGeom prst="rect">
-            <a:avLst/>
-          </a:prstGeom>
-          <a:noFill/>
-        </p:spPr>
-        <p:txBody>
-          <a:bodyPr wrap="square" anchor="ctr" lIns="0" rIns="0" tIns="0" bIns="0">
-            <a:spAutoFit/>
-          </a:bodyPr>
-          <a:lstStyle/>
-          <a:p>
-            <a:pPr algn="l">
-              <a:spcBef>
-                <a:spcPts val="0"/>
-              </a:spcBef>
-              <a:spcAft>
-                <a:spcPts val="0"/>
-              </a:spcAft>
-              <a:buNone/>
-            </a:pPr>
-            <a:r>
-              <a:rPr sz="1400" b="1" i="0">
-                <a:solidFill>
-                  <a:srgbClr val="182127"/>
-                </a:solidFill>
-                <a:latin typeface="Inter"/>
-                <a:cs typeface="Inter"/>
-              </a:rPr>
-              <a:t>Deployment  </a:t>
-            </a:r>
-            <a:r>
-              <a:rPr sz="1100" b="0" i="0">
-                <a:solidFill>
-                  <a:srgbClr val="5B666E"/>
-                </a:solidFill>
-                <a:latin typeface="Inter"/>
-                <a:cs typeface="Inter"/>
-              </a:rPr>
-              <a:t>— Docker container on Azure App Service (Linux B1, Central US), image via Azure Container Registry.</a:t>
-            </a:r>
-          </a:p>
-        </p:txBody>
-      </p:sp>
-      <p:sp>
-        <p:nvSpPr>
-          <p:cNvPr id="29" name="Rounded Rectangle 28"/>
-          <p:cNvSpPr/>
-          <p:nvPr/>
-        </p:nvSpPr>
-        <p:spPr>
-          <a:xfrm>
-            <a:off x="640080" y="5166360"/>
-            <a:ext cx="10881360" cy="960120"/>
-          </a:xfrm>
-          <a:prstGeom prst="roundRect">
-            <a:avLst>
-              <a:gd name="adj" fmla="val 6000"/>
-            </a:avLst>
-          </a:prstGeom>
-          <a:solidFill>
-            <a:srgbClr val="F7F8F9"/>
-          </a:solidFill>
-          <a:ln w="12700">
-            <a:solidFill>
-              <a:srgbClr val="E2E5E8"/>
-            </a:solidFill>
-          </a:ln>
-          <a:effectLst>
-            <a:outerShdw blurRad="90000" dist="38000" dir="5400000" rotWithShape="0">
-              <a:srgbClr val="182127">
-                <a:alpha val="16000"/>
-              </a:srgbClr>
-            </a:outerShdw>
-          </a:effectLst>
-        </p:spPr>
-        <p:style>
-          <a:lnRef idx="1">
-            <a:schemeClr val="accent1"/>
-          </a:lnRef>
-          <a:fillRef idx="3">
-            <a:schemeClr val="accent1"/>
-          </a:fillRef>
-          <a:effectRef idx="2">
-            <a:schemeClr val="accent1"/>
-          </a:effectRef>
-          <a:fontRef idx="minor">
-            <a:schemeClr val="lt1"/>
-          </a:fontRef>
-        </p:style>
-        <p:txBody>
-          <a:bodyPr rtlCol="0" anchor="ctr"/>
-          <a:lstStyle/>
-          <a:p>
-            <a:pPr algn="ctr"/>
-          </a:p>
-        </p:txBody>
-      </p:sp>
-      <p:sp>
-        <p:nvSpPr>
-          <p:cNvPr id="30" name="Rectangle 29"/>
-          <p:cNvSpPr/>
-          <p:nvPr/>
-        </p:nvSpPr>
-        <p:spPr>
-          <a:xfrm>
-            <a:off x="640080" y="5166360"/>
-            <a:ext cx="82296" cy="960120"/>
-          </a:xfrm>
-          <a:prstGeom prst="rect">
-            <a:avLst/>
-          </a:prstGeom>
-          <a:gradFill>
-            <a:gsLst>
-              <a:gs pos="0">
-                <a:srgbClr val="F4AD0B"/>
-              </a:gs>
-              <a:gs pos="50000">
-                <a:srgbClr val="FC7900"/>
-              </a:gs>
-              <a:gs pos="100000">
-                <a:srgbClr val="E3434A"/>
-              </a:gs>
-            </a:gsLst>
-            <a:lin ang="0" scaled="1"/>
-          </a:gradFill>
-          <a:ln>
-            <a:noFill/>
-          </a:ln>
-          <a:effectLst/>
-        </p:spPr>
-        <p:style>
-          <a:lnRef idx="1">
-            <a:schemeClr val="accent1"/>
-          </a:lnRef>
-          <a:fillRef idx="3">
-            <a:schemeClr val="accent1"/>
-          </a:fillRef>
-          <a:effectRef idx="2">
-            <a:schemeClr val="accent1"/>
-          </a:effectRef>
-          <a:fontRef idx="minor">
-            <a:schemeClr val="lt1"/>
-          </a:fontRef>
-        </p:style>
-        <p:txBody>
-          <a:bodyPr rtlCol="0" anchor="ctr"/>
-          <a:lstStyle/>
-          <a:p>
-            <a:pPr algn="ctr"/>
-          </a:p>
-        </p:txBody>
-      </p:sp>
-      <p:sp>
-        <p:nvSpPr>
-          <p:cNvPr id="31" name="TextBox 30"/>
-          <p:cNvSpPr txBox="1"/>
-          <p:nvPr/>
-        </p:nvSpPr>
-        <p:spPr>
-          <a:xfrm>
-            <a:off x="896112" y="5367528"/>
-            <a:ext cx="10369296" cy="594360"/>
+            <a:off x="640080" y="6089904"/>
+            <a:ext cx="10881360" cy="292608"/>
           </a:xfrm>
           <a:prstGeom prst="rect">
             <a:avLst/>
@@ -10807,53 +9540,31 @@
           </a:bodyPr>
           <a:lstStyle/>
           <a:p>
-            <a:pPr algn="l">
-              <a:spcBef>
-                <a:spcPts val="0"/>
-              </a:spcBef>
-              <a:spcAft>
-                <a:spcPts val="800"/>
-              </a:spcAft>
-              <a:buNone/>
-            </a:pPr>
-            <a:r>
-              <a:rPr sz="1450" b="1" i="0">
-                <a:solidFill>
-                  <a:srgbClr val="182127"/>
-                </a:solidFill>
-                <a:latin typeface="Inter"/>
-                <a:cs typeface="Inter"/>
-              </a:rPr>
-              <a:t>Why a single unit</a:t>
-            </a:r>
-          </a:p>
-          <a:p>
-            <a:pPr algn="l" indent="-219456" marL="219456">
-              <a:spcBef>
-                <a:spcPts val="0"/>
-              </a:spcBef>
-              <a:spcAft>
-                <a:spcPts val="600"/>
-              </a:spcAft>
-              <a:buFont typeface="Inter"/>
-              <a:buChar char="–"/>
-            </a:pPr>
-            <a:r>
-              <a:rPr sz="1250" b="0" i="0">
+            <a:pPr algn="ctr">
+              <a:spcBef>
+                <a:spcPts val="0"/>
+              </a:spcBef>
+              <a:spcAft>
+                <a:spcPts val="0"/>
+              </a:spcAft>
+              <a:buNone/>
+            </a:pPr>
+            <a:r>
+              <a:rPr sz="1100" b="0" i="1">
                 <a:solidFill>
                   <a:srgbClr val="5B666E"/>
                 </a:solidFill>
                 <a:latin typeface="Inter"/>
                 <a:cs typeface="Inter"/>
               </a:rPr>
-              <a:t>Avoids CORS configuration entirely and keeps the pilot's operational surface to one App Service resource, one deployment pipeline, one place to check logs.</a:t>
-            </a:r>
-          </a:p>
-        </p:txBody>
-      </p:sp>
-      <p:sp>
-        <p:nvSpPr>
-          <p:cNvPr id="32" name="TextBox 31"/>
+              <a:t>Single deployable unit — no CORS, one pipeline, one place for logs. Online path solid; offline ingestion dashed.</a:t>
+            </a:r>
+          </a:p>
+        </p:txBody>
+      </p:sp>
+      <p:sp>
+        <p:nvSpPr>
+          <p:cNvPr id="8" name="TextBox 7"/>
           <p:cNvSpPr txBox="1"/>
           <p:nvPr/>
         </p:nvSpPr>
@@ -10897,7 +9608,7 @@
       </p:sp>
       <p:sp>
         <p:nvSpPr>
-          <p:cNvPr id="33" name="TextBox 32"/>
+          <p:cNvPr id="9" name="TextBox 8"/>
           <p:cNvSpPr txBox="1"/>
           <p:nvPr/>
         </p:nvSpPr>
@@ -10941,7 +9652,7 @@
       </p:sp>
       <p:sp>
         <p:nvSpPr>
-          <p:cNvPr id="34" name="Rectangle 33"/>
+          <p:cNvPr id="10" name="Rectangle 9"/>
           <p:cNvSpPr/>
           <p:nvPr/>
         </p:nvSpPr>

</xml_diff>